<commit_message>
feat: Update deduplication threshold to 90% and enhance evaluation descriptions in schema
</commit_message>
<xml_diff>
--- a/Presentation_RAG_Aquila_v2.pptx
+++ b/Presentation_RAG_Aquila_v2.pptx
@@ -9492,7 +9492,7 @@
                 </a:solidFill>
                 <a:latin typeface="Segoe UI"/>
               </a:rPr>
-              <a:t>seuil 80% de tokens communs</a:t>
+              <a:t>seuil 90% de tokens communs</a:t>
             </a:r>
           </a:p>
         </p:txBody>
@@ -12124,7 +12124,7 @@
                 </a:solidFill>
                 <a:latin typeface="Segoe UI"/>
               </a:rPr>
-              <a:t>→ evaluate_components.py ne relance JAMAIS le pipeline : il relit uniquement ce fichier pour scorer chacune des 6 briques.</a:t>
+              <a:t>→ evaluate_components.py ne relance JAMAIS le pipeline : il relit uniquement ce fichier pour scorer chacune des 8 briques.</a:t>
             </a:r>
           </a:p>
         </p:txBody>
@@ -13052,7 +13052,7 @@
                 </a:solidFill>
                 <a:latin typeface="Segoe UI Semibold"/>
               </a:rPr>
-              <a:t>Évaluation par composant (6 briques)</a:t>
+              <a:t>Évaluation par composant (8 briques)</a:t>
             </a:r>
           </a:p>
         </p:txBody>
@@ -13066,7 +13066,7 @@
         <p:spPr>
           <a:xfrm>
             <a:off x="6263640" y="2697480"/>
-            <a:ext cx="5440680" cy="512064"/>
+            <a:ext cx="5440680" cy="422820"/>
           </a:xfrm>
           <a:prstGeom prst="roundRect">
             <a:avLst>
@@ -13114,7 +13114,7 @@
         <p:spPr>
           <a:xfrm>
             <a:off x="6263640" y="2697480"/>
-            <a:ext cx="64008" cy="512064"/>
+            <a:ext cx="64008" cy="422820"/>
           </a:xfrm>
           <a:prstGeom prst="rect">
             <a:avLst/>
@@ -13157,8 +13157,8 @@
         </p:nvSpPr>
         <p:spPr>
           <a:xfrm>
-            <a:off x="6473952" y="2734056"/>
-            <a:ext cx="1828800" cy="438912"/>
+            <a:off x="6473952" y="2727681"/>
+            <a:ext cx="1828800" cy="362417"/>
           </a:xfrm>
           <a:prstGeom prst="rect">
             <a:avLst/>
@@ -13177,7 +13177,7 @@
               </a:lnSpc>
             </a:pPr>
             <a:r>
-              <a:rPr sz="1100" b="1" i="0">
+              <a:rPr sz="908" b="1" i="0">
                 <a:solidFill>
                   <a:srgbClr val="0B1F3A"/>
                 </a:solidFill>
@@ -13196,8 +13196,8 @@
         </p:nvSpPr>
         <p:spPr>
           <a:xfrm>
-            <a:off x="8229600" y="2734056"/>
-            <a:ext cx="3383280" cy="438912"/>
+            <a:off x="8229600" y="2727681"/>
+            <a:ext cx="3383280" cy="362417"/>
           </a:xfrm>
           <a:prstGeom prst="rect">
             <a:avLst/>
@@ -13216,7 +13216,7 @@
               </a:lnSpc>
             </a:pPr>
             <a:r>
-              <a:rPr sz="930" b="0" i="0">
+              <a:rPr sz="767" b="0" i="0">
                 <a:solidFill>
                   <a:srgbClr val="5B6677"/>
                 </a:solidFill>
@@ -13235,8 +13235,8 @@
         </p:nvSpPr>
         <p:spPr>
           <a:xfrm>
-            <a:off x="6263640" y="3273552"/>
-            <a:ext cx="5440680" cy="512064"/>
+            <a:off x="6263640" y="3173152"/>
+            <a:ext cx="5440680" cy="422820"/>
           </a:xfrm>
           <a:prstGeom prst="roundRect">
             <a:avLst>
@@ -13283,8 +13283,8 @@
         </p:nvSpPr>
         <p:spPr>
           <a:xfrm>
-            <a:off x="6263640" y="3273552"/>
-            <a:ext cx="64008" cy="512064"/>
+            <a:off x="6263640" y="3173152"/>
+            <a:ext cx="64008" cy="422820"/>
           </a:xfrm>
           <a:prstGeom prst="rect">
             <a:avLst/>
@@ -13327,8 +13327,8 @@
         </p:nvSpPr>
         <p:spPr>
           <a:xfrm>
-            <a:off x="6473952" y="3310128"/>
-            <a:ext cx="1828800" cy="438912"/>
+            <a:off x="6473952" y="3203353"/>
+            <a:ext cx="1828800" cy="362417"/>
           </a:xfrm>
           <a:prstGeom prst="rect">
             <a:avLst/>
@@ -13347,7 +13347,7 @@
               </a:lnSpc>
             </a:pPr>
             <a:r>
-              <a:rPr sz="1100" b="1" i="0">
+              <a:rPr sz="908" b="1" i="0">
                 <a:solidFill>
                   <a:srgbClr val="0B1F3A"/>
                 </a:solidFill>
@@ -13366,8 +13366,8 @@
         </p:nvSpPr>
         <p:spPr>
           <a:xfrm>
-            <a:off x="8229600" y="3310128"/>
-            <a:ext cx="3383280" cy="438912"/>
+            <a:off x="8229600" y="3203353"/>
+            <a:ext cx="3383280" cy="362417"/>
           </a:xfrm>
           <a:prstGeom prst="rect">
             <a:avLst/>
@@ -13386,7 +13386,7 @@
               </a:lnSpc>
             </a:pPr>
             <a:r>
-              <a:rPr sz="930" b="0" i="0">
+              <a:rPr sz="767" b="0" i="0">
                 <a:solidFill>
                   <a:srgbClr val="5B6677"/>
                 </a:solidFill>
@@ -13405,8 +13405,8 @@
         </p:nvSpPr>
         <p:spPr>
           <a:xfrm>
-            <a:off x="6263640" y="3849624"/>
-            <a:ext cx="5440680" cy="512064"/>
+            <a:off x="6263640" y="3648824"/>
+            <a:ext cx="5440680" cy="422820"/>
           </a:xfrm>
           <a:prstGeom prst="roundRect">
             <a:avLst>
@@ -13453,8 +13453,8 @@
         </p:nvSpPr>
         <p:spPr>
           <a:xfrm>
-            <a:off x="6263640" y="3849624"/>
-            <a:ext cx="64008" cy="512064"/>
+            <a:off x="6263640" y="3648824"/>
+            <a:ext cx="64008" cy="422820"/>
           </a:xfrm>
           <a:prstGeom prst="rect">
             <a:avLst/>
@@ -13497,8 +13497,8 @@
         </p:nvSpPr>
         <p:spPr>
           <a:xfrm>
-            <a:off x="6473952" y="3886200"/>
-            <a:ext cx="1828800" cy="438912"/>
+            <a:off x="6473952" y="3679025"/>
+            <a:ext cx="1828800" cy="362417"/>
           </a:xfrm>
           <a:prstGeom prst="rect">
             <a:avLst/>
@@ -13517,7 +13517,7 @@
               </a:lnSpc>
             </a:pPr>
             <a:r>
-              <a:rPr sz="1100" b="1" i="0">
+              <a:rPr sz="908" b="1" i="0">
                 <a:solidFill>
                   <a:srgbClr val="0B1F3A"/>
                 </a:solidFill>
@@ -13536,8 +13536,8 @@
         </p:nvSpPr>
         <p:spPr>
           <a:xfrm>
-            <a:off x="8229600" y="3886200"/>
-            <a:ext cx="3383280" cy="438912"/>
+            <a:off x="8229600" y="3679025"/>
+            <a:ext cx="3383280" cy="362417"/>
           </a:xfrm>
           <a:prstGeom prst="rect">
             <a:avLst/>
@@ -13556,7 +13556,7 @@
               </a:lnSpc>
             </a:pPr>
             <a:r>
-              <a:rPr sz="930" b="0" i="0">
+              <a:rPr sz="767" b="0" i="0">
                 <a:solidFill>
                   <a:srgbClr val="5B6677"/>
                 </a:solidFill>
@@ -13575,8 +13575,8 @@
         </p:nvSpPr>
         <p:spPr>
           <a:xfrm>
-            <a:off x="6263640" y="4425696"/>
-            <a:ext cx="5440680" cy="512064"/>
+            <a:off x="6263640" y="4124496"/>
+            <a:ext cx="5440680" cy="422820"/>
           </a:xfrm>
           <a:prstGeom prst="roundRect">
             <a:avLst>
@@ -13623,8 +13623,8 @@
         </p:nvSpPr>
         <p:spPr>
           <a:xfrm>
-            <a:off x="6263640" y="4425696"/>
-            <a:ext cx="64008" cy="512064"/>
+            <a:off x="6263640" y="4124496"/>
+            <a:ext cx="64008" cy="422820"/>
           </a:xfrm>
           <a:prstGeom prst="rect">
             <a:avLst/>
@@ -13667,8 +13667,8 @@
         </p:nvSpPr>
         <p:spPr>
           <a:xfrm>
-            <a:off x="6473952" y="4462272"/>
-            <a:ext cx="1828800" cy="438912"/>
+            <a:off x="6473952" y="4154697"/>
+            <a:ext cx="1828800" cy="362417"/>
           </a:xfrm>
           <a:prstGeom prst="rect">
             <a:avLst/>
@@ -13687,7 +13687,7 @@
               </a:lnSpc>
             </a:pPr>
             <a:r>
-              <a:rPr sz="1100" b="1" i="0">
+              <a:rPr sz="908" b="1" i="0">
                 <a:solidFill>
                   <a:srgbClr val="0B1F3A"/>
                 </a:solidFill>
@@ -13706,8 +13706,8 @@
         </p:nvSpPr>
         <p:spPr>
           <a:xfrm>
-            <a:off x="8229600" y="4462272"/>
-            <a:ext cx="3383280" cy="438912"/>
+            <a:off x="8229600" y="4154697"/>
+            <a:ext cx="3383280" cy="362417"/>
           </a:xfrm>
           <a:prstGeom prst="rect">
             <a:avLst/>
@@ -13726,7 +13726,7 @@
               </a:lnSpc>
             </a:pPr>
             <a:r>
-              <a:rPr sz="930" b="0" i="0">
+              <a:rPr sz="767" b="0" i="0">
                 <a:solidFill>
                   <a:srgbClr val="5B6677"/>
                 </a:solidFill>
@@ -13745,8 +13745,8 @@
         </p:nvSpPr>
         <p:spPr>
           <a:xfrm>
-            <a:off x="6263640" y="5001768"/>
-            <a:ext cx="5440680" cy="512064"/>
+            <a:off x="6263640" y="4600168"/>
+            <a:ext cx="5440680" cy="422820"/>
           </a:xfrm>
           <a:prstGeom prst="roundRect">
             <a:avLst>
@@ -13793,8 +13793,8 @@
         </p:nvSpPr>
         <p:spPr>
           <a:xfrm>
-            <a:off x="6263640" y="5001768"/>
-            <a:ext cx="64008" cy="512064"/>
+            <a:off x="6263640" y="4600168"/>
+            <a:ext cx="64008" cy="422820"/>
           </a:xfrm>
           <a:prstGeom prst="rect">
             <a:avLst/>
@@ -13837,8 +13837,8 @@
         </p:nvSpPr>
         <p:spPr>
           <a:xfrm>
-            <a:off x="6473952" y="5038344"/>
-            <a:ext cx="1828800" cy="438912"/>
+            <a:off x="6473952" y="4630369"/>
+            <a:ext cx="1828800" cy="362417"/>
           </a:xfrm>
           <a:prstGeom prst="rect">
             <a:avLst/>
@@ -13857,7 +13857,7 @@
               </a:lnSpc>
             </a:pPr>
             <a:r>
-              <a:rPr sz="1100" b="1" i="0">
+              <a:rPr sz="908" b="1" i="0">
                 <a:solidFill>
                   <a:srgbClr val="0B1F3A"/>
                 </a:solidFill>
@@ -13876,8 +13876,8 @@
         </p:nvSpPr>
         <p:spPr>
           <a:xfrm>
-            <a:off x="8229600" y="5038344"/>
-            <a:ext cx="3383280" cy="438912"/>
+            <a:off x="8229600" y="4630369"/>
+            <a:ext cx="3383280" cy="362417"/>
           </a:xfrm>
           <a:prstGeom prst="rect">
             <a:avLst/>
@@ -13896,7 +13896,7 @@
               </a:lnSpc>
             </a:pPr>
             <a:r>
-              <a:rPr sz="930" b="0" i="0">
+              <a:rPr sz="767" b="0" i="0">
                 <a:solidFill>
                   <a:srgbClr val="5B6677"/>
                 </a:solidFill>
@@ -13915,8 +13915,8 @@
         </p:nvSpPr>
         <p:spPr>
           <a:xfrm>
-            <a:off x="6263640" y="5577840"/>
-            <a:ext cx="5440680" cy="512064"/>
+            <a:off x="6263640" y="5075840"/>
+            <a:ext cx="5440680" cy="422820"/>
           </a:xfrm>
           <a:prstGeom prst="roundRect">
             <a:avLst>
@@ -13963,8 +13963,8 @@
         </p:nvSpPr>
         <p:spPr>
           <a:xfrm>
-            <a:off x="6263640" y="5577840"/>
-            <a:ext cx="64008" cy="512064"/>
+            <a:off x="6263640" y="5075840"/>
+            <a:ext cx="64008" cy="422820"/>
           </a:xfrm>
           <a:prstGeom prst="rect">
             <a:avLst/>
@@ -14007,8 +14007,8 @@
         </p:nvSpPr>
         <p:spPr>
           <a:xfrm>
-            <a:off x="6473952" y="5614416"/>
-            <a:ext cx="1828800" cy="438912"/>
+            <a:off x="6473952" y="5106041"/>
+            <a:ext cx="1828800" cy="362417"/>
           </a:xfrm>
           <a:prstGeom prst="rect">
             <a:avLst/>
@@ -14027,7 +14027,7 @@
               </a:lnSpc>
             </a:pPr>
             <a:r>
-              <a:rPr sz="1100" b="1" i="0">
+              <a:rPr sz="908" b="1" i="0">
                 <a:solidFill>
                   <a:srgbClr val="0B1F3A"/>
                 </a:solidFill>
@@ -14046,8 +14046,8 @@
         </p:nvSpPr>
         <p:spPr>
           <a:xfrm>
-            <a:off x="8229600" y="5614416"/>
-            <a:ext cx="3383280" cy="438912"/>
+            <a:off x="8229600" y="5106041"/>
+            <a:ext cx="3383280" cy="362417"/>
           </a:xfrm>
           <a:prstGeom prst="rect">
             <a:avLst/>
@@ -14066,7 +14066,7 @@
               </a:lnSpc>
             </a:pPr>
             <a:r>
-              <a:rPr sz="930" b="0" i="0">
+              <a:rPr sz="767" b="0" i="0">
                 <a:solidFill>
                   <a:srgbClr val="5B6677"/>
                 </a:solidFill>
@@ -14196,6 +14196,346 @@
           <a:lstStyle/>
           <a:p>
             <a:pPr algn="ctr"/>
+          </a:p>
+        </p:txBody>
+      </p:sp>
+      <p:sp>
+        <p:nvSpPr>
+          <p:cNvPr id="59" name="Rounded Rectangle 51 newrow1"/>
+          <p:cNvSpPr/>
+          <p:nvPr/>
+        </p:nvSpPr>
+        <p:spPr>
+          <a:xfrm>
+            <a:off x="6263640" y="5551512"/>
+            <a:ext cx="5440680" cy="422820"/>
+          </a:xfrm>
+          <a:prstGeom prst="roundRect">
+            <a:avLst>
+              <a:gd name="adj" fmla="val 20000"/>
+            </a:avLst>
+          </a:prstGeom>
+          <a:solidFill>
+            <a:srgbClr val="FFFFFF"/>
+          </a:solidFill>
+          <a:ln w="12700">
+            <a:solidFill>
+              <a:srgbClr val="E3E8EE"/>
+            </a:solidFill>
+          </a:ln>
+          <a:effectLst/>
+        </p:spPr>
+        <p:style>
+          <a:lnRef idx="1">
+            <a:schemeClr val="accent1"/>
+          </a:lnRef>
+          <a:fillRef idx="3">
+            <a:schemeClr val="accent1"/>
+          </a:fillRef>
+          <a:effectRef idx="2">
+            <a:schemeClr val="accent1"/>
+          </a:effectRef>
+          <a:fontRef idx="minor">
+            <a:schemeClr val="lt1"/>
+          </a:fontRef>
+        </p:style>
+        <p:txBody>
+          <a:bodyPr rtlCol="0" anchor="ctr"/>
+          <a:lstStyle/>
+          <a:p>
+            <a:pPr algn="ctr"/>
+          </a:p>
+        </p:txBody>
+      </p:sp>
+      <p:sp>
+        <p:nvSpPr>
+          <p:cNvPr id="60" name="Rectangle 52 newrow1"/>
+          <p:cNvSpPr/>
+          <p:nvPr/>
+        </p:nvSpPr>
+        <p:spPr>
+          <a:xfrm>
+            <a:off x="6263640" y="5551512"/>
+            <a:ext cx="64008" cy="422820"/>
+          </a:xfrm>
+          <a:prstGeom prst="rect">
+            <a:avLst/>
+          </a:prstGeom>
+          <a:solidFill>
+            <a:srgbClr val="1B8A80"/>
+          </a:solidFill>
+          <a:ln>
+            <a:noFill/>
+          </a:ln>
+          <a:effectLst/>
+        </p:spPr>
+        <p:style>
+          <a:lnRef idx="1">
+            <a:schemeClr val="accent1"/>
+          </a:lnRef>
+          <a:fillRef idx="3">
+            <a:schemeClr val="accent1"/>
+          </a:fillRef>
+          <a:effectRef idx="2">
+            <a:schemeClr val="accent1"/>
+          </a:effectRef>
+          <a:fontRef idx="minor">
+            <a:schemeClr val="lt1"/>
+          </a:fontRef>
+        </p:style>
+        <p:txBody>
+          <a:bodyPr rtlCol="0" anchor="ctr"/>
+          <a:lstStyle/>
+          <a:p>
+            <a:pPr algn="ctr"/>
+          </a:p>
+        </p:txBody>
+      </p:sp>
+      <p:sp>
+        <p:nvSpPr>
+          <p:cNvPr id="61" name="TextBox 53 newrow1"/>
+          <p:cNvSpPr txBox="1"/>
+          <p:nvPr/>
+        </p:nvSpPr>
+        <p:spPr>
+          <a:xfrm>
+            <a:off x="6473952" y="5581713"/>
+            <a:ext cx="1828800" cy="362417"/>
+          </a:xfrm>
+          <a:prstGeom prst="rect">
+            <a:avLst/>
+          </a:prstGeom>
+          <a:noFill/>
+        </p:spPr>
+        <p:txBody>
+          <a:bodyPr wrap="square" anchor="ctr" lIns="0" rIns="0" tIns="0" bIns="0">
+            <a:spAutoFit/>
+          </a:bodyPr>
+          <a:lstStyle/>
+          <a:p>
+            <a:pPr algn="l">
+              <a:lnSpc>
+                <a:spcPct val="100000"/>
+              </a:lnSpc>
+            </a:pPr>
+            <a:r>
+              <a:rPr sz="908" b="1" i="0">
+                <a:solidFill>
+                  <a:srgbClr val="0B1F3A"/>
+                </a:solidFill>
+                <a:latin typeface="Segoe UI Semibold"/>
+              </a:rPr>
+              <a:t>⑦ Déduplication</a:t>
+            </a:r>
+          </a:p>
+        </p:txBody>
+      </p:sp>
+      <p:sp>
+        <p:nvSpPr>
+          <p:cNvPr id="62" name="TextBox 54 newrow1"/>
+          <p:cNvSpPr txBox="1"/>
+          <p:nvPr/>
+        </p:nvSpPr>
+        <p:spPr>
+          <a:xfrm>
+            <a:off x="8229600" y="5581713"/>
+            <a:ext cx="3383280" cy="362417"/>
+          </a:xfrm>
+          <a:prstGeom prst="rect">
+            <a:avLst/>
+          </a:prstGeom>
+          <a:noFill/>
+        </p:spPr>
+        <p:txBody>
+          <a:bodyPr wrap="square" anchor="ctr" lIns="0" rIns="0" tIns="0" bIns="0">
+            <a:spAutoFit/>
+          </a:bodyPr>
+          <a:lstStyle/>
+          <a:p>
+            <a:pPr algn="l">
+              <a:lnSpc>
+                <a:spcPct val="100000"/>
+              </a:lnSpc>
+            </a:pPr>
+            <a:r>
+              <a:rPr sz="767" b="0" i="0">
+                <a:solidFill>
+                  <a:srgbClr val="5B6677"/>
+                </a:solidFill>
+                <a:latin typeface="Segoe UI"/>
+              </a:rPr>
+              <a:t>Perte d’info réelle (chunk écarté vs conservé)</a:t>
+            </a:r>
+          </a:p>
+        </p:txBody>
+      </p:sp>
+      <p:sp>
+        <p:nvSpPr>
+          <p:cNvPr id="63" name="Rounded Rectangle 51 newrow2"/>
+          <p:cNvSpPr/>
+          <p:nvPr/>
+        </p:nvSpPr>
+        <p:spPr>
+          <a:xfrm>
+            <a:off x="6263640" y="6027184"/>
+            <a:ext cx="5440680" cy="422820"/>
+          </a:xfrm>
+          <a:prstGeom prst="roundRect">
+            <a:avLst>
+              <a:gd name="adj" fmla="val 20000"/>
+            </a:avLst>
+          </a:prstGeom>
+          <a:solidFill>
+            <a:srgbClr val="FFFFFF"/>
+          </a:solidFill>
+          <a:ln w="12700">
+            <a:solidFill>
+              <a:srgbClr val="E3E8EE"/>
+            </a:solidFill>
+          </a:ln>
+          <a:effectLst/>
+        </p:spPr>
+        <p:style>
+          <a:lnRef idx="1">
+            <a:schemeClr val="accent1"/>
+          </a:lnRef>
+          <a:fillRef idx="3">
+            <a:schemeClr val="accent1"/>
+          </a:fillRef>
+          <a:effectRef idx="2">
+            <a:schemeClr val="accent1"/>
+          </a:effectRef>
+          <a:fontRef idx="minor">
+            <a:schemeClr val="lt1"/>
+          </a:fontRef>
+        </p:style>
+        <p:txBody>
+          <a:bodyPr rtlCol="0" anchor="ctr"/>
+          <a:lstStyle/>
+          <a:p>
+            <a:pPr algn="ctr"/>
+          </a:p>
+        </p:txBody>
+      </p:sp>
+      <p:sp>
+        <p:nvSpPr>
+          <p:cNvPr id="64" name="Rectangle 52 newrow2"/>
+          <p:cNvSpPr/>
+          <p:nvPr/>
+        </p:nvSpPr>
+        <p:spPr>
+          <a:xfrm>
+            <a:off x="6263640" y="6027184"/>
+            <a:ext cx="64008" cy="422820"/>
+          </a:xfrm>
+          <a:prstGeom prst="rect">
+            <a:avLst/>
+          </a:prstGeom>
+          <a:solidFill>
+            <a:srgbClr val="1B8A80"/>
+          </a:solidFill>
+          <a:ln>
+            <a:noFill/>
+          </a:ln>
+          <a:effectLst/>
+        </p:spPr>
+        <p:style>
+          <a:lnRef idx="1">
+            <a:schemeClr val="accent1"/>
+          </a:lnRef>
+          <a:fillRef idx="3">
+            <a:schemeClr val="accent1"/>
+          </a:fillRef>
+          <a:effectRef idx="2">
+            <a:schemeClr val="accent1"/>
+          </a:effectRef>
+          <a:fontRef idx="minor">
+            <a:schemeClr val="lt1"/>
+          </a:fontRef>
+        </p:style>
+        <p:txBody>
+          <a:bodyPr rtlCol="0" anchor="ctr"/>
+          <a:lstStyle/>
+          <a:p>
+            <a:pPr algn="ctr"/>
+          </a:p>
+        </p:txBody>
+      </p:sp>
+      <p:sp>
+        <p:nvSpPr>
+          <p:cNvPr id="65" name="TextBox 53 newrow2"/>
+          <p:cNvSpPr txBox="1"/>
+          <p:nvPr/>
+        </p:nvSpPr>
+        <p:spPr>
+          <a:xfrm>
+            <a:off x="6473952" y="6057385"/>
+            <a:ext cx="1828800" cy="362417"/>
+          </a:xfrm>
+          <a:prstGeom prst="rect">
+            <a:avLst/>
+          </a:prstGeom>
+          <a:noFill/>
+        </p:spPr>
+        <p:txBody>
+          <a:bodyPr wrap="square" anchor="ctr" lIns="0" rIns="0" tIns="0" bIns="0">
+            <a:spAutoFit/>
+          </a:bodyPr>
+          <a:lstStyle/>
+          <a:p>
+            <a:pPr algn="l">
+              <a:lnSpc>
+                <a:spcPct val="100000"/>
+              </a:lnSpc>
+            </a:pPr>
+            <a:r>
+              <a:rPr sz="908" b="1" i="0">
+                <a:solidFill>
+                  <a:srgbClr val="0B1F3A"/>
+                </a:solidFill>
+                <a:latin typeface="Segoe UI Semibold"/>
+              </a:rPr>
+              <a:t>⑧ Fusion RRF</a:t>
+            </a:r>
+          </a:p>
+        </p:txBody>
+      </p:sp>
+      <p:sp>
+        <p:nvSpPr>
+          <p:cNvPr id="66" name="TextBox 54 newrow2"/>
+          <p:cNvSpPr txBox="1"/>
+          <p:nvPr/>
+        </p:nvSpPr>
+        <p:spPr>
+          <a:xfrm>
+            <a:off x="8229600" y="6057385"/>
+            <a:ext cx="3383280" cy="362417"/>
+          </a:xfrm>
+          <a:prstGeom prst="rect">
+            <a:avLst/>
+          </a:prstGeom>
+          <a:noFill/>
+        </p:spPr>
+        <p:txBody>
+          <a:bodyPr wrap="square" anchor="ctr" lIns="0" rIns="0" tIns="0" bIns="0">
+            <a:spAutoFit/>
+          </a:bodyPr>
+          <a:lstStyle/>
+          <a:p>
+            <a:pPr algn="l">
+              <a:lnSpc>
+                <a:spcPct val="100000"/>
+              </a:lnSpc>
+            </a:pPr>
+            <a:r>
+              <a:rPr sz="767" b="0" i="0">
+                <a:solidFill>
+                  <a:srgbClr val="5B6677"/>
+                </a:solidFill>
+                <a:latin typeface="Segoe UI"/>
+              </a:rPr>
+              <a:t>Sémantique vs BM25 vs fusion (complémentarité)</a:t>
+            </a:r>
           </a:p>
         </p:txBody>
       </p:sp>
@@ -29873,7 +30213,7 @@
                 </a:solidFill>
                 <a:latin typeface="Segoe UI"/>
               </a:rPr>
-              <a:t>▸ evaluate_components.py — 6 briques (relit le debug)</a:t>
+              <a:t>▸ evaluate_components.py — 8 briques (relit le debug)</a:t>
             </a:r>
           </a:p>
         </p:txBody>

</xml_diff>